<commit_message>
Align Demo Day materials with course guidance
</commit_message>
<xml_diff>
--- a/docs/demo-day/Smoothy-King-Demo-Day.pptx
+++ b/docs/demo-day/Smoothy-King-Demo-Day.pptx
@@ -2,17 +2,17 @@
 <file path=ppt/presentation.xml><?xml version="1.0" encoding="utf-8"?>
 <p:presentation xmlns:p="http://schemas.openxmlformats.org/presentationml/2006/main">
   <p:sldMasterIdLst>
-    <p:sldMasterId xmlns:r="http://schemas.openxmlformats.org/officeDocument/2006/relationships" id="2147483648" r:id="R9dcfaf5571f244a3"/>
+    <p:sldMasterId xmlns:r="http://schemas.openxmlformats.org/officeDocument/2006/relationships" id="2147483648" r:id="R2d8724031b924529"/>
   </p:sldMasterIdLst>
   <p:notesMasterIdLst>
-    <p:notesMasterId xmlns:r="http://schemas.openxmlformats.org/officeDocument/2006/relationships" r:id="R6bb55913854b4d9f"/>
+    <p:notesMasterId xmlns:r="http://schemas.openxmlformats.org/officeDocument/2006/relationships" r:id="R55e2753d6a16496c"/>
   </p:notesMasterIdLst>
   <p:sldIdLst>
-    <p:sldId xmlns:r="http://schemas.openxmlformats.org/officeDocument/2006/relationships" id="256" r:id="R0ed962009887415e"/>
-    <p:sldId xmlns:r="http://schemas.openxmlformats.org/officeDocument/2006/relationships" id="257" r:id="Rffc88493a9684baa"/>
-    <p:sldId xmlns:r="http://schemas.openxmlformats.org/officeDocument/2006/relationships" id="258" r:id="Rb8de374480b64508"/>
-    <p:sldId xmlns:r="http://schemas.openxmlformats.org/officeDocument/2006/relationships" id="259" r:id="R4bba121a81604417"/>
-    <p:sldId xmlns:r="http://schemas.openxmlformats.org/officeDocument/2006/relationships" id="260" r:id="R8021a60f47614f92"/>
+    <p:sldId xmlns:r="http://schemas.openxmlformats.org/officeDocument/2006/relationships" id="256" r:id="Re828e4d628e54bea"/>
+    <p:sldId xmlns:r="http://schemas.openxmlformats.org/officeDocument/2006/relationships" id="257" r:id="Rb7cabf0dcd9249a2"/>
+    <p:sldId xmlns:r="http://schemas.openxmlformats.org/officeDocument/2006/relationships" id="258" r:id="Rd36cfe114e32487b"/>
+    <p:sldId xmlns:r="http://schemas.openxmlformats.org/officeDocument/2006/relationships" id="259" r:id="R0338ed5a121b44fe"/>
+    <p:sldId xmlns:r="http://schemas.openxmlformats.org/officeDocument/2006/relationships" id="260" r:id="R1cc47d3902c84201"/>
   </p:sldIdLst>
   <p:sldSz cx="12192000" cy="6858000"/>
   <p:notesSz cx="6858000" cy="9144000"/>
@@ -811,7 +811,7 @@
           <a:lstStyle xmlns:a="http://schemas.openxmlformats.org/drawingml/2006/main"/>
           <a:p xmlns:a="http://schemas.openxmlformats.org/drawingml/2006/main">
             <a:r>
-              <a:t>Close with the product’s actual value and volunteer two limitations. Owning the gaps makes the safety boundary credible. Invite questions, then return to the live product if useful.</a:t>
+              <a:t>Name one limit clearly: this version does not predict taste. Explain that flavor-family tags are not the same as pairing or satisfaction data. The next step is feedback plus tested pairing rules, not a marketing promise. Close: start with a goal, leave with a checked plan. Invite questions.</a:t>
             </a:r>
           </a:p>
           <a:p xmlns:a="http://schemas.openxmlformats.org/drawingml/2006/main">
@@ -832,6 +832,11 @@
           <a:p xmlns:a="http://schemas.openxmlformats.org/drawingml/2006/main">
             <a:r>
               <a:t>- docs/demo-day.md — direct Q&amp;A answers.</a:t>
+            </a:r>
+          </a:p>
+          <a:p xmlns:a="http://schemas.openxmlformats.org/drawingml/2006/main">
+            <a:r>
+              <a:t>- /Users/hadocter/.codex/attachments/b5e08e6c-ca7a-48a2-8dea-1427d382aee3/pasted-text.txt — Demo Day guidance.</a:t>
             </a:r>
           </a:p>
         </p:txBody>
@@ -899,7 +904,7 @@
   </p:cSld>
   <p:clrMap bg1="lt1" tx1="dk1" bg2="lt2" tx2="dk2" accent1="accent1" accent2="accent2" accent3="accent3" accent4="accent4" accent5="accent5" accent6="accent6" hlink="hlink" folHlink="folHlink"/>
   <p:sldLayoutIdLst>
-    <p:sldLayoutId xmlns:r="http://schemas.openxmlformats.org/officeDocument/2006/relationships" id="2147483649" r:id="Rd61209e7a9944282"/>
+    <p:sldLayoutId xmlns:r="http://schemas.openxmlformats.org/officeDocument/2006/relationships" id="2147483649" r:id="Ra6090e65f83f4164"/>
   </p:sldLayoutIdLst>
   <p:txStyles>
     <p:titleStyle>
@@ -1454,7 +1459,7 @@
           <p:nvPr/>
         </p:nvPicPr>
         <p:blipFill>
-          <a:blip xmlns:r="http://schemas.openxmlformats.org/officeDocument/2006/relationships" xmlns:a="http://schemas.openxmlformats.org/drawingml/2006/main" r:embed="Raef2e8f7a4524df0"/>
+          <a:blip xmlns:r="http://schemas.openxmlformats.org/officeDocument/2006/relationships" xmlns:a="http://schemas.openxmlformats.org/drawingml/2006/main" r:embed="Rb7a968f045494c0c"/>
           <a:srcRect xmlns:a="http://schemas.openxmlformats.org/drawingml/2006/main" l="25917" t="0" r="25917" b="0"/>
           <a:stretch xmlns:a="http://schemas.openxmlformats.org/drawingml/2006/main">
             <a:fillRect l="0" t="0" r="0" b="0"/>
@@ -1475,7 +1480,7 @@
           <p:cNvPr id="2" name="eyebrow">
             <a:extLst xmlns:a="http://schemas.openxmlformats.org/drawingml/2006/main">
               <a:ext uri="{FF2B5EF4-FFF2-40B4-BE49-F238E27FC236}">
-                <a16:creationId xmlns:a16="http://schemas.microsoft.com/office/drawing/2014/main" id="{156FB4B8-AD19-4805-B523-B5E1D3DA165A}"/>
+                <a16:creationId xmlns:a16="http://schemas.microsoft.com/office/drawing/2014/main" id="{839383DA-1412-4E51-A828-A1F8E3D4B80D}"/>
               </a:ext>
             </a:extLst>
           </p:cNvPr>
@@ -1525,7 +1530,7 @@
           <p:cNvPr id="3" name="title">
             <a:extLst xmlns:a="http://schemas.openxmlformats.org/drawingml/2006/main">
               <a:ext uri="{FF2B5EF4-FFF2-40B4-BE49-F238E27FC236}">
-                <a16:creationId xmlns:a16="http://schemas.microsoft.com/office/drawing/2014/main" id="{0725D1A6-FB08-41B5-AFD8-0FED8D29BEC7}"/>
+                <a16:creationId xmlns:a16="http://schemas.microsoft.com/office/drawing/2014/main" id="{A503F26E-C874-45D4-A60A-EC7969468560}"/>
               </a:ext>
             </a:extLst>
           </p:cNvPr>
@@ -1609,7 +1614,7 @@
           <p:cNvPr id="4" name="subtitle">
             <a:extLst xmlns:a="http://schemas.openxmlformats.org/drawingml/2006/main">
               <a:ext uri="{FF2B5EF4-FFF2-40B4-BE49-F238E27FC236}">
-                <a16:creationId xmlns:a16="http://schemas.microsoft.com/office/drawing/2014/main" id="{509888AE-046E-4037-90E6-5E0AD30718E5}"/>
+                <a16:creationId xmlns:a16="http://schemas.microsoft.com/office/drawing/2014/main" id="{95EA7277-BC06-4382-9531-66E72B0465AD}"/>
               </a:ext>
             </a:extLst>
           </p:cNvPr>
@@ -1659,7 +1664,7 @@
           <p:cNvPr id="5" name="live-label">
             <a:extLst xmlns:a="http://schemas.openxmlformats.org/drawingml/2006/main">
               <a:ext uri="{FF2B5EF4-FFF2-40B4-BE49-F238E27FC236}">
-                <a16:creationId xmlns:a16="http://schemas.microsoft.com/office/drawing/2014/main" id="{ABC16250-7179-4B45-88D0-FA1BD815D530}"/>
+                <a16:creationId xmlns:a16="http://schemas.microsoft.com/office/drawing/2014/main" id="{8517E2B2-F7E5-4910-A912-CBC6CFEA3A48}"/>
               </a:ext>
             </a:extLst>
           </p:cNvPr>
@@ -1709,7 +1714,7 @@
           <p:cNvPr id="6" name="">
             <a:extLst xmlns:a="http://schemas.openxmlformats.org/drawingml/2006/main">
               <a:ext uri="{FF2B5EF4-FFF2-40B4-BE49-F238E27FC236}">
-                <a16:creationId xmlns:a16="http://schemas.microsoft.com/office/drawing/2014/main" id="{5E064D5A-A1E7-4083-9AC6-85E0A4296574}"/>
+                <a16:creationId xmlns:a16="http://schemas.microsoft.com/office/drawing/2014/main" id="{CB5D3787-6DA8-4BDF-9284-4C422FE7420D}"/>
               </a:ext>
             </a:extLst>
           </p:cNvPr>
@@ -1759,7 +1764,7 @@
           <p:cNvPr id="7" name="">
             <a:extLst xmlns:a="http://schemas.openxmlformats.org/drawingml/2006/main">
               <a:ext uri="{FF2B5EF4-FFF2-40B4-BE49-F238E27FC236}">
-                <a16:creationId xmlns:a16="http://schemas.microsoft.com/office/drawing/2014/main" id="{930FE7BF-24D8-4114-9799-8556A3738C18}"/>
+                <a16:creationId xmlns:a16="http://schemas.microsoft.com/office/drawing/2014/main" id="{0DFCBF81-AD26-410D-814E-9C8727E37CD5}"/>
               </a:ext>
             </a:extLst>
           </p:cNvPr>
@@ -1807,7 +1812,7 @@
     </p:spTree>
     <p:extLst>
       <p:ext uri="{BB962C8B-B14F-4D97-AF65-F5344CB8AC3E}">
-        <p14:creationId xmlns:p14="http://schemas.microsoft.com/office/powerpoint/2010/main" val="845641231"/>
+        <p14:creationId xmlns:p14="http://schemas.microsoft.com/office/powerpoint/2010/main" val="1208313416"/>
       </p:ext>
     </p:extLst>
   </p:cSld>
@@ -1838,7 +1843,7 @@
           <p:cNvPr id="8" name="">
             <a:extLst xmlns:a="http://schemas.openxmlformats.org/drawingml/2006/main">
               <a:ext uri="{FF2B5EF4-FFF2-40B4-BE49-F238E27FC236}">
-                <a16:creationId xmlns:a16="http://schemas.microsoft.com/office/drawing/2014/main" id="{DAD3B131-4A5C-4499-B798-C759E149233F}"/>
+                <a16:creationId xmlns:a16="http://schemas.microsoft.com/office/drawing/2014/main" id="{D3F2AF10-6038-47AF-BCDE-6F8C170EF943}"/>
               </a:ext>
             </a:extLst>
           </p:cNvPr>
@@ -1888,7 +1893,7 @@
           <p:cNvPr id="2" name="">
             <a:extLst xmlns:a="http://schemas.openxmlformats.org/drawingml/2006/main">
               <a:ext uri="{FF2B5EF4-FFF2-40B4-BE49-F238E27FC236}">
-                <a16:creationId xmlns:a16="http://schemas.microsoft.com/office/drawing/2014/main" id="{D68001E1-BC28-4F6B-89C9-D906310F80BA}"/>
+                <a16:creationId xmlns:a16="http://schemas.microsoft.com/office/drawing/2014/main" id="{B1239E00-3CDF-45EB-AC02-15CCA2CC1FE2}"/>
               </a:ext>
             </a:extLst>
           </p:cNvPr>
@@ -1955,7 +1960,7 @@
           <p:cNvPr id="3" name="">
             <a:extLst xmlns:a="http://schemas.openxmlformats.org/drawingml/2006/main">
               <a:ext uri="{FF2B5EF4-FFF2-40B4-BE49-F238E27FC236}">
-                <a16:creationId xmlns:a16="http://schemas.microsoft.com/office/drawing/2014/main" id="{D74D10FD-1669-464E-AFCD-7A3001A10D20}"/>
+                <a16:creationId xmlns:a16="http://schemas.microsoft.com/office/drawing/2014/main" id="{2E4DDCF0-FC6A-4494-9C1B-39560D922F7D}"/>
               </a:ext>
             </a:extLst>
           </p:cNvPr>
@@ -2005,7 +2010,7 @@
           <p:cNvPr id="4" name="">
             <a:extLst xmlns:a="http://schemas.openxmlformats.org/drawingml/2006/main">
               <a:ext uri="{FF2B5EF4-FFF2-40B4-BE49-F238E27FC236}">
-                <a16:creationId xmlns:a16="http://schemas.microsoft.com/office/drawing/2014/main" id="{7FF2C35B-FBD0-49B0-8F11-85E06C06DD56}"/>
+                <a16:creationId xmlns:a16="http://schemas.microsoft.com/office/drawing/2014/main" id="{1DC8DA14-2B8C-4CCF-AA78-1C098ED63A7B}"/>
               </a:ext>
             </a:extLst>
           </p:cNvPr>
@@ -2059,7 +2064,7 @@
           <p:nvPr/>
         </p:nvPicPr>
         <p:blipFill>
-          <a:blip xmlns:r="http://schemas.openxmlformats.org/officeDocument/2006/relationships" xmlns:a="http://schemas.openxmlformats.org/drawingml/2006/main" r:embed="Rc4ee8a2c0a164ae5"/>
+          <a:blip xmlns:r="http://schemas.openxmlformats.org/officeDocument/2006/relationships" xmlns:a="http://schemas.openxmlformats.org/drawingml/2006/main" r:embed="R6506147b96b84b77"/>
           <a:srcRect xmlns:a="http://schemas.openxmlformats.org/drawingml/2006/main" l="16333" t="0" r="16333" b="0"/>
           <a:stretch xmlns:a="http://schemas.openxmlformats.org/drawingml/2006/main">
             <a:fillRect l="0" t="0" r="0" b="0"/>
@@ -2082,7 +2087,7 @@
           <p:cNvPr id="6" name="">
             <a:extLst xmlns:a="http://schemas.openxmlformats.org/drawingml/2006/main">
               <a:ext uri="{FF2B5EF4-FFF2-40B4-BE49-F238E27FC236}">
-                <a16:creationId xmlns:a16="http://schemas.microsoft.com/office/drawing/2014/main" id="{3CEADEFB-6316-44BB-9B7C-DDB53AEAC07E}"/>
+                <a16:creationId xmlns:a16="http://schemas.microsoft.com/office/drawing/2014/main" id="{570AEE6E-5F6C-4842-B69E-0BE10891A7C6}"/>
               </a:ext>
             </a:extLst>
           </p:cNvPr>
@@ -2132,7 +2137,7 @@
           <p:cNvPr id="7" name="">
             <a:extLst xmlns:a="http://schemas.openxmlformats.org/drawingml/2006/main">
               <a:ext uri="{FF2B5EF4-FFF2-40B4-BE49-F238E27FC236}">
-                <a16:creationId xmlns:a16="http://schemas.microsoft.com/office/drawing/2014/main" id="{E251A411-F368-4369-9404-907702F9D520}"/>
+                <a16:creationId xmlns:a16="http://schemas.microsoft.com/office/drawing/2014/main" id="{DDB74FAA-04B6-4177-9218-92D6C9DEAA2E}"/>
               </a:ext>
             </a:extLst>
           </p:cNvPr>
@@ -2180,7 +2185,7 @@
     </p:spTree>
     <p:extLst>
       <p:ext uri="{BB962C8B-B14F-4D97-AF65-F5344CB8AC3E}">
-        <p14:creationId xmlns:p14="http://schemas.microsoft.com/office/powerpoint/2010/main" val="1718429336"/>
+        <p14:creationId xmlns:p14="http://schemas.microsoft.com/office/powerpoint/2010/main" val="1237877439"/>
       </p:ext>
     </p:extLst>
   </p:cSld>
@@ -2211,7 +2216,7 @@
           <p:cNvPr id="8" name="">
             <a:extLst xmlns:a="http://schemas.openxmlformats.org/drawingml/2006/main">
               <a:ext uri="{FF2B5EF4-FFF2-40B4-BE49-F238E27FC236}">
-                <a16:creationId xmlns:a16="http://schemas.microsoft.com/office/drawing/2014/main" id="{178F22A2-10AE-43D0-A22A-9F5B8804B74E}"/>
+                <a16:creationId xmlns:a16="http://schemas.microsoft.com/office/drawing/2014/main" id="{DFF8171B-5246-4D5A-A739-2AFE0514B9BA}"/>
               </a:ext>
             </a:extLst>
           </p:cNvPr>
@@ -2261,7 +2266,7 @@
           <p:cNvPr id="2" name="">
             <a:extLst xmlns:a="http://schemas.openxmlformats.org/drawingml/2006/main">
               <a:ext uri="{FF2B5EF4-FFF2-40B4-BE49-F238E27FC236}">
-                <a16:creationId xmlns:a16="http://schemas.microsoft.com/office/drawing/2014/main" id="{8BC08EE8-C5E1-4353-ACBA-0F80CFC852BC}"/>
+                <a16:creationId xmlns:a16="http://schemas.microsoft.com/office/drawing/2014/main" id="{BDDE19D2-BB1B-4329-8871-2BDC9F87C7E3}"/>
               </a:ext>
             </a:extLst>
           </p:cNvPr>
@@ -2328,7 +2333,7 @@
           <p:cNvPr id="3" name="">
             <a:extLst xmlns:a="http://schemas.openxmlformats.org/drawingml/2006/main">
               <a:ext uri="{FF2B5EF4-FFF2-40B4-BE49-F238E27FC236}">
-                <a16:creationId xmlns:a16="http://schemas.microsoft.com/office/drawing/2014/main" id="{DCFEA627-4187-4EA5-8ADC-AC860133051C}"/>
+                <a16:creationId xmlns:a16="http://schemas.microsoft.com/office/drawing/2014/main" id="{C3B2DFD3-5164-4502-811C-80B75B89CE57}"/>
               </a:ext>
             </a:extLst>
           </p:cNvPr>
@@ -2412,7 +2417,7 @@
           <p:cNvPr id="4" name="">
             <a:extLst xmlns:a="http://schemas.openxmlformats.org/drawingml/2006/main">
               <a:ext uri="{FF2B5EF4-FFF2-40B4-BE49-F238E27FC236}">
-                <a16:creationId xmlns:a16="http://schemas.microsoft.com/office/drawing/2014/main" id="{EA4DFDEE-5CDF-4A4B-9A6A-C0CF2E536D92}"/>
+                <a16:creationId xmlns:a16="http://schemas.microsoft.com/office/drawing/2014/main" id="{383B9E61-BC85-4826-9384-1DB77047501C}"/>
               </a:ext>
             </a:extLst>
           </p:cNvPr>
@@ -2466,7 +2471,7 @@
           <p:nvPr/>
         </p:nvPicPr>
         <p:blipFill>
-          <a:blip xmlns:r="http://schemas.openxmlformats.org/officeDocument/2006/relationships" xmlns:a="http://schemas.openxmlformats.org/drawingml/2006/main" r:embed="Rdbf3cb3f0ab94105"/>
+          <a:blip xmlns:r="http://schemas.openxmlformats.org/officeDocument/2006/relationships" xmlns:a="http://schemas.openxmlformats.org/drawingml/2006/main" r:embed="Rf46fa2a71c794a28"/>
           <a:srcRect xmlns:a="http://schemas.openxmlformats.org/drawingml/2006/main" l="15065" t="0" r="15065" b="0"/>
           <a:stretch xmlns:a="http://schemas.openxmlformats.org/drawingml/2006/main">
             <a:fillRect l="0" t="0" r="0" b="0"/>
@@ -2489,7 +2494,7 @@
           <p:cNvPr id="6" name="">
             <a:extLst xmlns:a="http://schemas.openxmlformats.org/drawingml/2006/main">
               <a:ext uri="{FF2B5EF4-FFF2-40B4-BE49-F238E27FC236}">
-                <a16:creationId xmlns:a16="http://schemas.microsoft.com/office/drawing/2014/main" id="{5D810194-371D-4A15-9750-AD3ED3302030}"/>
+                <a16:creationId xmlns:a16="http://schemas.microsoft.com/office/drawing/2014/main" id="{9151F827-DCA4-489A-94C6-F29DD8A847B3}"/>
               </a:ext>
             </a:extLst>
           </p:cNvPr>
@@ -2539,7 +2544,7 @@
           <p:cNvPr id="7" name="">
             <a:extLst xmlns:a="http://schemas.openxmlformats.org/drawingml/2006/main">
               <a:ext uri="{FF2B5EF4-FFF2-40B4-BE49-F238E27FC236}">
-                <a16:creationId xmlns:a16="http://schemas.microsoft.com/office/drawing/2014/main" id="{827494AA-8DAE-4898-A292-C4B1E5DEF39E}"/>
+                <a16:creationId xmlns:a16="http://schemas.microsoft.com/office/drawing/2014/main" id="{0288A973-C1B3-4554-A3F9-0CF5CF5B18F7}"/>
               </a:ext>
             </a:extLst>
           </p:cNvPr>
@@ -2587,7 +2592,7 @@
     </p:spTree>
     <p:extLst>
       <p:ext uri="{BB962C8B-B14F-4D97-AF65-F5344CB8AC3E}">
-        <p14:creationId xmlns:p14="http://schemas.microsoft.com/office/powerpoint/2010/main" val="973755115"/>
+        <p14:creationId xmlns:p14="http://schemas.microsoft.com/office/powerpoint/2010/main" val="2066169901"/>
       </p:ext>
     </p:extLst>
   </p:cSld>
@@ -2618,7 +2623,7 @@
           <p:cNvPr id="10" name="">
             <a:extLst xmlns:a="http://schemas.openxmlformats.org/drawingml/2006/main">
               <a:ext uri="{FF2B5EF4-FFF2-40B4-BE49-F238E27FC236}">
-                <a16:creationId xmlns:a16="http://schemas.microsoft.com/office/drawing/2014/main" id="{86362A29-E628-4EC8-B61D-EED1C2D5A033}"/>
+                <a16:creationId xmlns:a16="http://schemas.microsoft.com/office/drawing/2014/main" id="{61B79043-7FC2-4966-9015-43B94A00CD09}"/>
               </a:ext>
             </a:extLst>
           </p:cNvPr>
@@ -2668,7 +2673,7 @@
           <p:cNvPr id="2" name="">
             <a:extLst xmlns:a="http://schemas.openxmlformats.org/drawingml/2006/main">
               <a:ext uri="{FF2B5EF4-FFF2-40B4-BE49-F238E27FC236}">
-                <a16:creationId xmlns:a16="http://schemas.microsoft.com/office/drawing/2014/main" id="{14FCF5DA-699C-4FAC-991A-743FF41C34BE}"/>
+                <a16:creationId xmlns:a16="http://schemas.microsoft.com/office/drawing/2014/main" id="{7E95F6E3-7FDA-47BE-A3AC-C300A36D56D5}"/>
               </a:ext>
             </a:extLst>
           </p:cNvPr>
@@ -2735,7 +2740,7 @@
           <p:cNvPr id="3" name="">
             <a:extLst xmlns:a="http://schemas.openxmlformats.org/drawingml/2006/main">
               <a:ext uri="{FF2B5EF4-FFF2-40B4-BE49-F238E27FC236}">
-                <a16:creationId xmlns:a16="http://schemas.microsoft.com/office/drawing/2014/main" id="{2566BEB7-5AD4-4CF8-B374-15ACFB7714F6}"/>
+                <a16:creationId xmlns:a16="http://schemas.microsoft.com/office/drawing/2014/main" id="{4149AA70-26D9-4382-ACD0-C50F43145E1E}"/>
               </a:ext>
             </a:extLst>
           </p:cNvPr>
@@ -2785,7 +2790,7 @@
           <p:cNvPr id="4" name="">
             <a:extLst xmlns:a="http://schemas.openxmlformats.org/drawingml/2006/main">
               <a:ext uri="{FF2B5EF4-FFF2-40B4-BE49-F238E27FC236}">
-                <a16:creationId xmlns:a16="http://schemas.microsoft.com/office/drawing/2014/main" id="{5C3D6CC4-C60D-4A2F-A3EF-67DB1AB2CDC8}"/>
+                <a16:creationId xmlns:a16="http://schemas.microsoft.com/office/drawing/2014/main" id="{3510AD9B-C765-450D-9151-BBDE8FA0A749}"/>
               </a:ext>
             </a:extLst>
           </p:cNvPr>
@@ -2869,7 +2874,7 @@
           <p:cNvPr id="5" name="">
             <a:extLst xmlns:a="http://schemas.openxmlformats.org/drawingml/2006/main">
               <a:ext uri="{FF2B5EF4-FFF2-40B4-BE49-F238E27FC236}">
-                <a16:creationId xmlns:a16="http://schemas.microsoft.com/office/drawing/2014/main" id="{EDC3C894-9FF4-4BFA-AEF6-DB6410A0939F}"/>
+                <a16:creationId xmlns:a16="http://schemas.microsoft.com/office/drawing/2014/main" id="{BDBE6F0D-3AEB-4AD8-BB1C-2FFA9130399A}"/>
               </a:ext>
             </a:extLst>
           </p:cNvPr>
@@ -2919,7 +2924,7 @@
           <p:cNvPr id="6" name="">
             <a:extLst xmlns:a="http://schemas.openxmlformats.org/drawingml/2006/main">
               <a:ext uri="{FF2B5EF4-FFF2-40B4-BE49-F238E27FC236}">
-                <a16:creationId xmlns:a16="http://schemas.microsoft.com/office/drawing/2014/main" id="{B4C61F8C-8F0F-4CBF-9D44-9F5CDDC42214}"/>
+                <a16:creationId xmlns:a16="http://schemas.microsoft.com/office/drawing/2014/main" id="{0A782604-D4D6-4BE5-BBC9-45F5A78EFDD4}"/>
               </a:ext>
             </a:extLst>
           </p:cNvPr>
@@ -3003,7 +3008,7 @@
           <p:cNvPr id="7" name="">
             <a:extLst xmlns:a="http://schemas.openxmlformats.org/drawingml/2006/main">
               <a:ext uri="{FF2B5EF4-FFF2-40B4-BE49-F238E27FC236}">
-                <a16:creationId xmlns:a16="http://schemas.microsoft.com/office/drawing/2014/main" id="{993660A6-0E90-4C2D-B79A-A7C39160E13D}"/>
+                <a16:creationId xmlns:a16="http://schemas.microsoft.com/office/drawing/2014/main" id="{7288511D-ABB6-4192-A479-22639CE2F721}"/>
               </a:ext>
             </a:extLst>
           </p:cNvPr>
@@ -3053,7 +3058,7 @@
           <p:cNvPr id="8" name="">
             <a:extLst xmlns:a="http://schemas.openxmlformats.org/drawingml/2006/main">
               <a:ext uri="{FF2B5EF4-FFF2-40B4-BE49-F238E27FC236}">
-                <a16:creationId xmlns:a16="http://schemas.microsoft.com/office/drawing/2014/main" id="{0603CDA7-5506-4827-9CF5-37CB134B1FD6}"/>
+                <a16:creationId xmlns:a16="http://schemas.microsoft.com/office/drawing/2014/main" id="{75ECFAC0-9545-4841-ADD2-A2972678E586}"/>
               </a:ext>
             </a:extLst>
           </p:cNvPr>
@@ -3103,7 +3108,7 @@
           <p:cNvPr id="9" name="">
             <a:extLst xmlns:a="http://schemas.openxmlformats.org/drawingml/2006/main">
               <a:ext uri="{FF2B5EF4-FFF2-40B4-BE49-F238E27FC236}">
-                <a16:creationId xmlns:a16="http://schemas.microsoft.com/office/drawing/2014/main" id="{A0472F03-F2BF-499F-A2A3-1D410C5DF92A}"/>
+                <a16:creationId xmlns:a16="http://schemas.microsoft.com/office/drawing/2014/main" id="{E251C808-A586-492E-B8F4-7ABC1A17EDF3}"/>
               </a:ext>
             </a:extLst>
           </p:cNvPr>
@@ -3151,7 +3156,7 @@
     </p:spTree>
     <p:extLst>
       <p:ext uri="{BB962C8B-B14F-4D97-AF65-F5344CB8AC3E}">
-        <p14:creationId xmlns:p14="http://schemas.microsoft.com/office/powerpoint/2010/main" val="1586532881"/>
+        <p14:creationId xmlns:p14="http://schemas.microsoft.com/office/powerpoint/2010/main" val="1494683215"/>
       </p:ext>
     </p:extLst>
   </p:cSld>
@@ -3182,7 +3187,7 @@
           <p:cNvPr id="10" name="">
             <a:extLst xmlns:a="http://schemas.openxmlformats.org/drawingml/2006/main">
               <a:ext uri="{FF2B5EF4-FFF2-40B4-BE49-F238E27FC236}">
-                <a16:creationId xmlns:a16="http://schemas.microsoft.com/office/drawing/2014/main" id="{7DCA9A9C-DA60-40F0-A2AA-7D12CEEE47C1}"/>
+                <a16:creationId xmlns:a16="http://schemas.microsoft.com/office/drawing/2014/main" id="{58ABF42D-E978-4FD1-91C6-A6FF6FC2D947}"/>
               </a:ext>
             </a:extLst>
           </p:cNvPr>
@@ -3194,7 +3199,7 @@
         <p:spPr>
           <a:xfrm xmlns:a="http://schemas.openxmlformats.org/drawingml/2006/main">
             <a:off x="685800" y="666750"/>
-            <a:ext cx="3429000" cy="247650"/>
+            <a:ext cx="4095750" cy="247650"/>
           </a:xfrm>
           <a:prstGeom xmlns:a="http://schemas.openxmlformats.org/drawingml/2006/main" prst="rect">
             <a:avLst/>
@@ -3222,7 +3227,7 @@
                   <a:srgbClr val="245844"/>
                 </a:solidFill>
               </a:rPr>
-              <a:t>READY FOR A LIVE DEMO</a:t>
+              <a:t>ONE LIMIT, SAID OUT LOUD</a:t>
             </a:r>
           </a:p>
         </p:txBody>
@@ -3232,7 +3237,7 @@
           <p:cNvPr id="2" name="">
             <a:extLst xmlns:a="http://schemas.openxmlformats.org/drawingml/2006/main">
               <a:ext uri="{FF2B5EF4-FFF2-40B4-BE49-F238E27FC236}">
-                <a16:creationId xmlns:a16="http://schemas.microsoft.com/office/drawing/2014/main" id="{F1E1EF18-B930-474B-97E9-43F63C1132F9}"/>
+                <a16:creationId xmlns:a16="http://schemas.microsoft.com/office/drawing/2014/main" id="{ACDFD27F-8F46-414E-817E-7B76087DBEE8}"/>
               </a:ext>
             </a:extLst>
           </p:cNvPr>
@@ -3244,7 +3249,7 @@
         <p:spPr>
           <a:xfrm xmlns:a="http://schemas.openxmlformats.org/drawingml/2006/main">
             <a:off x="685800" y="1295400"/>
-            <a:ext cx="6191250" cy="1428750"/>
+            <a:ext cx="7905750" cy="1428750"/>
           </a:xfrm>
           <a:prstGeom xmlns:a="http://schemas.openxmlformats.org/drawingml/2006/main" prst="rect">
             <a:avLst/>
@@ -3272,7 +3277,7 @@
                   <a:srgbClr val="173E32"/>
                 </a:solidFill>
               </a:rPr>
-              <a:t>A useful plan is better</a:t>
+              <a:t>It does not predict</a:t>
             </a:r>
           </a:p>
           <a:p xmlns:a="http://schemas.openxmlformats.org/drawingml/2006/main">
@@ -3289,7 +3294,7 @@
                   <a:srgbClr val="173E32"/>
                 </a:solidFill>
               </a:rPr>
-              <a:t>than a beautiful guess.</a:t>
+              <a:t>whether it will taste great.</a:t>
             </a:r>
           </a:p>
         </p:txBody>
@@ -3299,7 +3304,7 @@
           <p:cNvPr id="3" name="">
             <a:extLst xmlns:a="http://schemas.openxmlformats.org/drawingml/2006/main">
               <a:ext uri="{FF2B5EF4-FFF2-40B4-BE49-F238E27FC236}">
-                <a16:creationId xmlns:a16="http://schemas.microsoft.com/office/drawing/2014/main" id="{35FE6762-54B2-4665-9B41-59C1F07A5390}"/>
+                <a16:creationId xmlns:a16="http://schemas.microsoft.com/office/drawing/2014/main" id="{D9DCEA68-7936-4990-A5D0-304FDCFE6397}"/>
               </a:ext>
             </a:extLst>
           </p:cNvPr>
@@ -3339,7 +3344,7 @@
                   <a:srgbClr val="245844"/>
                 </a:solidFill>
               </a:rPr>
-              <a:t>What works today</a:t>
+              <a:t>Why</a:t>
             </a:r>
           </a:p>
         </p:txBody>
@@ -3349,7 +3354,7 @@
           <p:cNvPr id="4" name="">
             <a:extLst xmlns:a="http://schemas.openxmlformats.org/drawingml/2006/main">
               <a:ext uri="{FF2B5EF4-FFF2-40B4-BE49-F238E27FC236}">
-                <a16:creationId xmlns:a16="http://schemas.microsoft.com/office/drawing/2014/main" id="{88CDC424-569D-461D-9CE6-05EA737612CF}"/>
+                <a16:creationId xmlns:a16="http://schemas.microsoft.com/office/drawing/2014/main" id="{CC493A93-2038-45F1-8285-643BB6513DB1}"/>
               </a:ext>
             </a:extLst>
           </p:cNvPr>
@@ -3389,7 +3394,7 @@
                   <a:srgbClr val="61766D"/>
                 </a:solidFill>
               </a:rPr>
-              <a:t>Goal → checked smoothie → weekly plan</a:t>
+              <a:t>We match flavor families,</a:t>
             </a:r>
           </a:p>
           <a:p xmlns:a="http://schemas.openxmlformats.org/drawingml/2006/main">
@@ -3406,7 +3411,7 @@
                   <a:srgbClr val="61766D"/>
                 </a:solidFill>
               </a:rPr>
-              <a:t>Account-level privacy and authentication</a:t>
+              <a:t>but do not yet have pairing</a:t>
             </a:r>
           </a:p>
           <a:p xmlns:a="http://schemas.openxmlformats.org/drawingml/2006/main">
@@ -3423,7 +3428,7 @@
                   <a:srgbClr val="61766D"/>
                 </a:solidFill>
               </a:rPr>
-              <a:t>A deployable container with a health check</a:t>
+              <a:t>or post-drink satisfaction data.</a:t>
             </a:r>
           </a:p>
         </p:txBody>
@@ -3433,7 +3438,7 @@
           <p:cNvPr id="5" name="">
             <a:extLst xmlns:a="http://schemas.openxmlformats.org/drawingml/2006/main">
               <a:ext uri="{FF2B5EF4-FFF2-40B4-BE49-F238E27FC236}">
-                <a16:creationId xmlns:a16="http://schemas.microsoft.com/office/drawing/2014/main" id="{4EA14B5F-ECB5-460E-BD9D-22CB0591020B}"/>
+                <a16:creationId xmlns:a16="http://schemas.microsoft.com/office/drawing/2014/main" id="{5710C20D-414F-4E9B-BF7C-7A1E88C42747}"/>
               </a:ext>
             </a:extLst>
           </p:cNvPr>
@@ -3445,7 +3450,7 @@
         <p:spPr>
           <a:xfrm xmlns:a="http://schemas.openxmlformats.org/drawingml/2006/main">
             <a:off x="6572250" y="3524250"/>
-            <a:ext cx="2667000" cy="304800"/>
+            <a:ext cx="3810000" cy="304800"/>
           </a:xfrm>
           <a:prstGeom xmlns:a="http://schemas.openxmlformats.org/drawingml/2006/main" prst="rect">
             <a:avLst/>
@@ -3473,7 +3478,7 @@
                   <a:srgbClr val="245844"/>
                 </a:solidFill>
               </a:rPr>
-              <a:t>What comes next</a:t>
+              <a:t>What we would do next</a:t>
             </a:r>
           </a:p>
         </p:txBody>
@@ -3483,7 +3488,7 @@
           <p:cNvPr id="6" name="">
             <a:extLst xmlns:a="http://schemas.openxmlformats.org/drawingml/2006/main">
               <a:ext uri="{FF2B5EF4-FFF2-40B4-BE49-F238E27FC236}">
-                <a16:creationId xmlns:a16="http://schemas.microsoft.com/office/drawing/2014/main" id="{6C7451AB-96D7-47FD-B7E8-EBE026543B3F}"/>
+                <a16:creationId xmlns:a16="http://schemas.microsoft.com/office/drawing/2014/main" id="{AA449F46-E841-4E27-A0BE-B5450C8FCE02}"/>
               </a:ext>
             </a:extLst>
           </p:cNvPr>
@@ -3495,7 +3500,7 @@
         <p:spPr>
           <a:xfrm xmlns:a="http://schemas.openxmlformats.org/drawingml/2006/main">
             <a:off x="6572250" y="4000500"/>
-            <a:ext cx="4476750" cy="1314450"/>
+            <a:ext cx="4095750" cy="1314450"/>
           </a:xfrm>
           <a:prstGeom xmlns:a="http://schemas.openxmlformats.org/drawingml/2006/main" prst="rect">
             <a:avLst/>
@@ -3523,7 +3528,7 @@
                   <a:srgbClr val="61766D"/>
                 </a:solidFill>
               </a:rPr>
-              <a:t>Taste pairing and adaptation</a:t>
+              <a:t>Collect feedback and test</a:t>
             </a:r>
           </a:p>
           <a:p xmlns:a="http://schemas.openxmlformats.org/drawingml/2006/main">
@@ -3540,7 +3545,7 @@
                   <a:srgbClr val="61766D"/>
                 </a:solidFill>
               </a:rPr>
-              <a:t>Shaker-only routes for no-blender users</a:t>
+              <a:t>pairing rules before claiming</a:t>
             </a:r>
           </a:p>
           <a:p xmlns:a="http://schemas.openxmlformats.org/drawingml/2006/main">
@@ -3557,7 +3562,7 @@
                   <a:srgbClr val="61766D"/>
                 </a:solidFill>
               </a:rPr>
-              <a:t>Medication/pregnancy interaction data</a:t>
+              <a:t>better taste.</a:t>
             </a:r>
           </a:p>
         </p:txBody>
@@ -3567,7 +3572,7 @@
           <p:cNvPr id="7" name="">
             <a:extLst xmlns:a="http://schemas.openxmlformats.org/drawingml/2006/main">
               <a:ext uri="{FF2B5EF4-FFF2-40B4-BE49-F238E27FC236}">
-                <a16:creationId xmlns:a16="http://schemas.microsoft.com/office/drawing/2014/main" id="{ACC6099C-66FD-45C5-B99C-76D46EB1CB17}"/>
+                <a16:creationId xmlns:a16="http://schemas.microsoft.com/office/drawing/2014/main" id="{3EC25285-AA56-4115-9D9D-3FB137F7A473}"/>
               </a:ext>
             </a:extLst>
           </p:cNvPr>
@@ -3617,7 +3622,7 @@
           <p:cNvPr id="8" name="">
             <a:extLst xmlns:a="http://schemas.openxmlformats.org/drawingml/2006/main">
               <a:ext uri="{FF2B5EF4-FFF2-40B4-BE49-F238E27FC236}">
-                <a16:creationId xmlns:a16="http://schemas.microsoft.com/office/drawing/2014/main" id="{CA780D8D-A434-4E1C-9A5F-410AA3148C02}"/>
+                <a16:creationId xmlns:a16="http://schemas.microsoft.com/office/drawing/2014/main" id="{A114FE5B-8A89-453E-A632-D26BA39B05B7}"/>
               </a:ext>
             </a:extLst>
           </p:cNvPr>
@@ -3667,7 +3672,7 @@
           <p:cNvPr id="9" name="">
             <a:extLst xmlns:a="http://schemas.openxmlformats.org/drawingml/2006/main">
               <a:ext uri="{FF2B5EF4-FFF2-40B4-BE49-F238E27FC236}">
-                <a16:creationId xmlns:a16="http://schemas.microsoft.com/office/drawing/2014/main" id="{2771073F-9D05-4B6C-870A-726D7FD99D4D}"/>
+                <a16:creationId xmlns:a16="http://schemas.microsoft.com/office/drawing/2014/main" id="{29AACA78-05D5-43B2-8D07-655A1BA5AF0F}"/>
               </a:ext>
             </a:extLst>
           </p:cNvPr>
@@ -3715,7 +3720,7 @@
     </p:spTree>
     <p:extLst>
       <p:ext uri="{BB962C8B-B14F-4D97-AF65-F5344CB8AC3E}">
-        <p14:creationId xmlns:p14="http://schemas.microsoft.com/office/powerpoint/2010/main" val="1879468918"/>
+        <p14:creationId xmlns:p14="http://schemas.microsoft.com/office/powerpoint/2010/main" val="95304144"/>
       </p:ext>
     </p:extLst>
   </p:cSld>

</xml_diff>